<commit_message>
Replace comics with technical illustrations in the blue deck
Frames 01-05 now use blue HUD/schematic illustrations (target lock,
training formula, five-step path, operator workstation, scaling network)
instead of cartoon comics; alt text updated to match.

Co-Authored-By: Claude Opus 5.5 <noreply@anthropic.com>
Claude-Session: https://claude.ai/code/session_01QqHU1Mec7wAVsmzx9ZzXpr
</commit_message>
<xml_diff>
--- a/FP-2_v23_blue.pptx
+++ b/FP-2_v23_blue.pptx
@@ -2845,7 +2845,7 @@
       </p:sp>
       <p:pic>
         <p:nvPicPr>
-          <p:cNvPr id="4" name="Комікс 01" descr="Комікс: військовий показує великий палець — «Хочеш зробити добре — зроби сам!»">    </p:cNvPr>
+          <p:cNvPr id="4" name="Ілюстрація 01" descr="Ілюстрація: БпЛА в прицілі, три результати школи — екіпажі, результативність, показники">    </p:cNvPr>
           <p:cNvPicPr>
             <a:picLocks noChangeAspect="1"/>
           </p:cNvPicPr>
@@ -4669,7 +4669,7 @@
       </p:sp>
       <p:pic>
         <p:nvPicPr>
-          <p:cNvPr id="4" name="Комікс 02" descr="Комікс: військовий під літаками — «Досвід. Навчальна програма. Технічне оснащення»">    </p:cNvPr>
+          <p:cNvPr id="4" name="Ілюстрація 02" descr="Схема: бойовий досвід, навчальна база і технічне оснащення дають пілота або штурмана">    </p:cNvPr>
           <p:cNvPicPr>
             <a:picLocks noChangeAspect="1"/>
           </p:cNvPicPr>
@@ -5841,7 +5841,7 @@
       </p:sp>
       <p:pic>
         <p:nvPicPr>
-          <p:cNvPr id="4" name="Комікс 03" descr="Комікс із п’яти кадрів: шлях навчання від відбору до фахівця">    </p:cNvPr>
+          <p:cNvPr id="4" name="Ілюстрація 03" descr="Схема шляху навчання: п’ять кроків від відбору до фахівця високого класу">    </p:cNvPr>
           <p:cNvPicPr>
             <a:picLocks noChangeAspect="1"/>
           </p:cNvPicPr>
@@ -6876,7 +6876,7 @@
       </p:sp>
       <p:pic>
         <p:nvPicPr>
-          <p:cNvPr id="4" name="Комікс 04" descr="Комікс: досвідчені пілоти підказують курсанту за пультом керування">    </p:cNvPr>
+          <p:cNvPr id="4" name="Ілюстрація 04" descr="Схема робочого місця оператора: симулятор, пульт керування, зв’язок і маршрут">    </p:cNvPr>
           <p:cNvPicPr>
             <a:picLocks noChangeAspect="1"/>
           </p:cNvPicPr>
@@ -9499,7 +9499,7 @@
       </p:sp>
       <p:pic>
         <p:nvPicPr>
-          <p:cNvPr id="17" name="Комікс 05" descr="Комікс: рій БпЛА типу «крило» і графік зростання">    </p:cNvPr>
+          <p:cNvPr id="17" name="Ілюстрація 05" descr="Схема масштабування: центр і нові навчальні пункти, група БпЛА типу «крило»">    </p:cNvPr>
           <p:cNvPicPr>
             <a:picLocks noChangeAspect="1"/>
           </p:cNvPicPr>

</xml_diff>